<commit_message>
A: chapter-23 panels and pptx (Actions).
</commit_message>
<xml_diff>
--- a/chapter-23/Duff_Jerusalem_1922-1938.pptx
+++ b/chapter-23/Duff_Jerusalem_1922-1938.pptx
@@ -3337,6 +3337,198 @@
           </a:p>
         </p:txBody>
       </p:sp>
+      <p:pic>
+        <p:nvPicPr>
+          <p:cNvPr id="5" name="Picture 4" descr="01-haifa-quay.jpg"/>
+          <p:cNvPicPr>
+            <a:picLocks noChangeAspect="1"/>
+          </p:cNvPicPr>
+          <p:nvPr/>
+        </p:nvPicPr>
+        <p:blipFill>
+          <a:blip r:embed="rId2"/>
+          <a:stretch>
+            <a:fillRect/>
+          </a:stretch>
+        </p:blipFill>
+        <p:spPr>
+          <a:xfrm>
+            <a:off x="8549640" y="365760"/>
+            <a:ext cx="4677156" cy="3118104"/>
+          </a:xfrm>
+          <a:prstGeom prst="rect">
+            <a:avLst/>
+          </a:prstGeom>
+        </p:spPr>
+      </p:pic>
+      <p:pic>
+        <p:nvPicPr>
+          <p:cNvPr id="6" name="Picture 5" descr="02-inspector-kit.jpg"/>
+          <p:cNvPicPr>
+            <a:picLocks noChangeAspect="1"/>
+          </p:cNvPicPr>
+          <p:nvPr/>
+        </p:nvPicPr>
+        <p:blipFill>
+          <a:blip r:embed="rId3"/>
+          <a:stretch>
+            <a:fillRect/>
+          </a:stretch>
+        </p:blipFill>
+        <p:spPr>
+          <a:xfrm>
+            <a:off x="13336524" y="365760"/>
+            <a:ext cx="4677156" cy="3118104"/>
+          </a:xfrm>
+          <a:prstGeom prst="rect">
+            <a:avLst/>
+          </a:prstGeom>
+        </p:spPr>
+      </p:pic>
+      <p:pic>
+        <p:nvPicPr>
+          <p:cNvPr id="7" name="Picture 6" descr="03-baton-lane.jpg"/>
+          <p:cNvPicPr>
+            <a:picLocks noChangeAspect="1"/>
+          </p:cNvPicPr>
+          <p:nvPr/>
+        </p:nvPicPr>
+        <p:blipFill>
+          <a:blip r:embed="rId4"/>
+          <a:stretch>
+            <a:fillRect/>
+          </a:stretch>
+        </p:blipFill>
+        <p:spPr>
+          <a:xfrm>
+            <a:off x="8549640" y="3490722"/>
+            <a:ext cx="4677156" cy="3118104"/>
+          </a:xfrm>
+          <a:prstGeom prst="rect">
+            <a:avLst/>
+          </a:prstGeom>
+        </p:spPr>
+      </p:pic>
+      <p:pic>
+        <p:nvPicPr>
+          <p:cNvPr id="8" name="Picture 7" descr="04-dismissal-desk.jpg"/>
+          <p:cNvPicPr>
+            <a:picLocks noChangeAspect="1"/>
+          </p:cNvPicPr>
+          <p:nvPr/>
+        </p:nvPicPr>
+        <p:blipFill>
+          <a:blip r:embed="rId5"/>
+          <a:stretch>
+            <a:fillRect/>
+          </a:stretch>
+        </p:blipFill>
+        <p:spPr>
+          <a:xfrm>
+            <a:off x="13336524" y="3490722"/>
+            <a:ext cx="4677156" cy="3118104"/>
+          </a:xfrm>
+          <a:prstGeom prst="rect">
+            <a:avLst/>
+          </a:prstGeom>
+        </p:spPr>
+      </p:pic>
+      <p:pic>
+        <p:nvPicPr>
+          <p:cNvPr id="9" name="Picture 8" descr="05-swollen-yard.jpg"/>
+          <p:cNvPicPr>
+            <a:picLocks noChangeAspect="1"/>
+          </p:cNvPicPr>
+          <p:nvPr/>
+        </p:nvPicPr>
+        <p:blipFill>
+          <a:blip r:embed="rId6"/>
+          <a:stretch>
+            <a:fillRect/>
+          </a:stretch>
+        </p:blipFill>
+        <p:spPr>
+          <a:xfrm>
+            <a:off x="8549640" y="6615684"/>
+            <a:ext cx="4677156" cy="3118104"/>
+          </a:xfrm>
+          <a:prstGeom prst="rect">
+            <a:avLst/>
+          </a:prstGeom>
+        </p:spPr>
+      </p:pic>
+      <p:pic>
+        <p:nvPicPr>
+          <p:cNvPr id="10" name="Picture 9" descr="06-telegram-house.jpg"/>
+          <p:cNvPicPr>
+            <a:picLocks noChangeAspect="1"/>
+          </p:cNvPicPr>
+          <p:nvPr/>
+        </p:nvPicPr>
+        <p:blipFill>
+          <a:blip r:embed="rId7"/>
+          <a:stretch>
+            <a:fillRect/>
+          </a:stretch>
+        </p:blipFill>
+        <p:spPr>
+          <a:xfrm>
+            <a:off x="13336524" y="6615684"/>
+            <a:ext cx="4677156" cy="3118104"/>
+          </a:xfrm>
+          <a:prstGeom prst="rect">
+            <a:avLst/>
+          </a:prstGeom>
+        </p:spPr>
+      </p:pic>
+      <p:pic>
+        <p:nvPicPr>
+          <p:cNvPr id="11" name="Picture 10" descr="07-screen-alley.jpg"/>
+          <p:cNvPicPr>
+            <a:picLocks noChangeAspect="1"/>
+          </p:cNvPicPr>
+          <p:nvPr/>
+        </p:nvPicPr>
+        <p:blipFill>
+          <a:blip r:embed="rId8"/>
+          <a:stretch>
+            <a:fillRect/>
+          </a:stretch>
+        </p:blipFill>
+        <p:spPr>
+          <a:xfrm>
+            <a:off x="8549640" y="9740646"/>
+            <a:ext cx="4677156" cy="3118104"/>
+          </a:xfrm>
+          <a:prstGeom prst="rect">
+            <a:avLst/>
+          </a:prstGeom>
+        </p:spPr>
+      </p:pic>
+      <p:pic>
+        <p:nvPicPr>
+          <p:cNvPr id="12" name="Picture 11" descr="08-mandate-gate.jpg"/>
+          <p:cNvPicPr>
+            <a:picLocks noChangeAspect="1"/>
+          </p:cNvPicPr>
+          <p:nvPr/>
+        </p:nvPicPr>
+        <p:blipFill>
+          <a:blip r:embed="rId9"/>
+          <a:stretch>
+            <a:fillRect/>
+          </a:stretch>
+        </p:blipFill>
+        <p:spPr>
+          <a:xfrm>
+            <a:off x="13336524" y="9740646"/>
+            <a:ext cx="4677156" cy="3118104"/>
+          </a:xfrm>
+          <a:prstGeom prst="rect">
+            <a:avLst/>
+          </a:prstGeom>
+        </p:spPr>
+      </p:pic>
     </p:spTree>
   </p:cSld>
   <p:clrMapOvr>

</xml_diff>